<commit_message>
Add standalone script for Phase 4 re-run with tuned parameters
- Implemented `run_phase4_rerun.py` to execute the Phase 4 re-run pipeline.
- Configured to save figures to `outputs/figures/` and results to `outputs/phase4_results.json`.
- Integrated drift visualization, dataset generation, training of static and adaptive GRUs, and evaluation of multiple decoders.
- Included analysis of temporal segments and supervision sweep for adaptive GRU.
</commit_message>
<xml_diff>
--- a/presentation/adaptive_qec_slides.pptx
+++ b/presentation/adaptive_qec_slides.pptx
@@ -5146,7 +5146,11 @@
             </a:r>
             <a:br/>
             <a:r>
-              <a:t>pseudo-labels → works!</a:t>
+              <a:t>pseudo-labels → prevents</a:t>
+            </a:r>
+            <a:br/>
+            <a:r>
+              <a:t>pseudo-label collapse</a:t>
             </a:r>
           </a:p>
         </p:txBody>
@@ -5238,13 +5242,13 @@
             <a:pPr algn="l">
               <a:defRPr sz="1400" b="0">
                 <a:solidFill>
-                  <a:srgbClr val="FAB387"/>
-                </a:solidFill>
-                <a:latin typeface="Calibri"/>
-              </a:defRPr>
-            </a:pPr>
-            <a:r>
-              <a:t>⚠️ Fill in after running notebook</a:t>
+                  <a:srgbClr val="A6ADC8"/>
+                </a:solidFill>
+                <a:latin typeface="Calibri"/>
+              </a:defRPr>
+            </a:pPr>
+            <a:r>
+              <a:t>Overall accuracy under drifting non-idealities (N=100, T=400)</a:t>
             </a:r>
           </a:p>
         </p:txBody>
@@ -5360,7 +5364,7 @@
                         </a:defRPr>
                       </a:pPr>
                       <a:r>
-                        <a:t>____%</a:t>
+                        <a:t>70.0%</a:t>
                       </a:r>
                     </a:p>
                   </a:txBody>
@@ -5410,7 +5414,7 @@
                         </a:defRPr>
                       </a:pPr>
                       <a:r>
-                        <a:t>____%</a:t>
+                        <a:t>76.5%</a:t>
                       </a:r>
                     </a:p>
                   </a:txBody>
@@ -5460,7 +5464,7 @@
                         </a:defRPr>
                       </a:pPr>
                       <a:r>
-                        <a:t>____%</a:t>
+                        <a:t>86.1%</a:t>
                       </a:r>
                     </a:p>
                   </a:txBody>
@@ -5510,7 +5514,7 @@
                         </a:defRPr>
                       </a:pPr>
                       <a:r>
-                        <a:t>____%</a:t>
+                        <a:t>78.4%</a:t>
                       </a:r>
                     </a:p>
                   </a:txBody>
@@ -5536,7 +5540,7 @@
                         </a:defRPr>
                       </a:pPr>
                       <a:r>
-                        <a:t>Adaptive (hybrid)</a:t>
+                        <a:t>Adaptive (hybrid, every 20)</a:t>
                       </a:r>
                     </a:p>
                   </a:txBody>
@@ -5560,7 +5564,7 @@
                         </a:defRPr>
                       </a:pPr>
                       <a:r>
-                        <a:t>____%</a:t>
+                        <a:t>85.7%</a:t>
                       </a:r>
                     </a:p>
                   </a:txBody>
@@ -5670,7 +5674,7 @@
         <p:spPr>
           <a:xfrm>
             <a:off x="731520" y="914400"/>
-            <a:ext cx="4572000" cy="365760"/>
+            <a:ext cx="9144000" cy="365760"/>
           </a:xfrm>
           <a:prstGeom prst="rect">
             <a:avLst/>
@@ -5686,13 +5690,13 @@
             <a:pPr algn="l">
               <a:defRPr sz="1200" b="0">
                 <a:solidFill>
-                  <a:srgbClr val="FAB387"/>
-                </a:solidFill>
-                <a:latin typeface="Calibri"/>
-              </a:defRPr>
-            </a:pPr>
-            <a:r>
-              <a:t>⚠️ Fill in segment data after running notebook</a:t>
+                  <a:srgbClr val="A6ADC8"/>
+                </a:solidFill>
+                <a:latin typeface="Calibri"/>
+              </a:defRPr>
+            </a:pPr>
+            <a:r>
+              <a:t>Static drop 13.2pp · Hybrid drop 14.7pp · Pseudo-label collapses to 12–46% across all segments</a:t>
             </a:r>
           </a:p>
         </p:txBody>
@@ -5908,7 +5912,7 @@
                         </a:defRPr>
                       </a:pPr>
                       <a:r>
-                        <a:t>___</a:t>
+                        <a:t>76.0%</a:t>
                       </a:r>
                     </a:p>
                   </a:txBody>
@@ -5932,7 +5936,7 @@
                         </a:defRPr>
                       </a:pPr>
                       <a:r>
-                        <a:t>___</a:t>
+                        <a:t>90.1%</a:t>
                       </a:r>
                     </a:p>
                   </a:txBody>
@@ -5956,7 +5960,7 @@
                         </a:defRPr>
                       </a:pPr>
                       <a:r>
-                        <a:t>___</a:t>
+                        <a:t>89.2%</a:t>
                       </a:r>
                     </a:p>
                   </a:txBody>
@@ -5980,7 +5984,7 @@
                         </a:defRPr>
                       </a:pPr>
                       <a:r>
-                        <a:t>___</a:t>
+                        <a:t>45.8%</a:t>
                       </a:r>
                     </a:p>
                   </a:txBody>
@@ -6004,7 +6008,7 @@
                         </a:defRPr>
                       </a:pPr>
                       <a:r>
-                        <a:t>___</a:t>
+                        <a:t>88.2%</a:t>
                       </a:r>
                     </a:p>
                   </a:txBody>
@@ -6054,7 +6058,7 @@
                         </a:defRPr>
                       </a:pPr>
                       <a:r>
-                        <a:t>___</a:t>
+                        <a:t>80.5%</a:t>
                       </a:r>
                     </a:p>
                   </a:txBody>
@@ -6078,7 +6082,7 @@
                         </a:defRPr>
                       </a:pPr>
                       <a:r>
-                        <a:t>___</a:t>
+                        <a:t>85.9%</a:t>
                       </a:r>
                     </a:p>
                   </a:txBody>
@@ -6102,7 +6106,7 @@
                         </a:defRPr>
                       </a:pPr>
                       <a:r>
-                        <a:t>___</a:t>
+                        <a:t>92.4%</a:t>
                       </a:r>
                     </a:p>
                   </a:txBody>
@@ -6126,7 +6130,7 @@
                         </a:defRPr>
                       </a:pPr>
                       <a:r>
-                        <a:t>___</a:t>
+                        <a:t>20.9%</a:t>
                       </a:r>
                     </a:p>
                   </a:txBody>
@@ -6150,7 +6154,7 @@
                         </a:defRPr>
                       </a:pPr>
                       <a:r>
-                        <a:t>___</a:t>
+                        <a:t>93.4%</a:t>
                       </a:r>
                     </a:p>
                   </a:txBody>
@@ -6200,7 +6204,7 @@
                         </a:defRPr>
                       </a:pPr>
                       <a:r>
-                        <a:t>___</a:t>
+                        <a:t>75.8%</a:t>
                       </a:r>
                     </a:p>
                   </a:txBody>
@@ -6224,7 +6228,7 @@
                         </a:defRPr>
                       </a:pPr>
                       <a:r>
-                        <a:t>___</a:t>
+                        <a:t>75.1%</a:t>
                       </a:r>
                     </a:p>
                   </a:txBody>
@@ -6248,7 +6252,7 @@
                         </a:defRPr>
                       </a:pPr>
                       <a:r>
-                        <a:t>___</a:t>
+                        <a:t>90.8%</a:t>
                       </a:r>
                     </a:p>
                   </a:txBody>
@@ -6272,7 +6276,7 @@
                         </a:defRPr>
                       </a:pPr>
                       <a:r>
-                        <a:t>___</a:t>
+                        <a:t>12.2%</a:t>
                       </a:r>
                     </a:p>
                   </a:txBody>
@@ -6296,7 +6300,7 @@
                         </a:defRPr>
                       </a:pPr>
                       <a:r>
-                        <a:t>___</a:t>
+                        <a:t>89.9%</a:t>
                       </a:r>
                     </a:p>
                   </a:txBody>
@@ -6346,7 +6350,7 @@
                         </a:defRPr>
                       </a:pPr>
                       <a:r>
-                        <a:t>___</a:t>
+                        <a:t>57.6%</a:t>
                       </a:r>
                     </a:p>
                   </a:txBody>
@@ -6370,7 +6374,7 @@
                         </a:defRPr>
                       </a:pPr>
                       <a:r>
-                        <a:t>___</a:t>
+                        <a:t>66.1%</a:t>
                       </a:r>
                     </a:p>
                   </a:txBody>
@@ -6394,7 +6398,7 @@
                         </a:defRPr>
                       </a:pPr>
                       <a:r>
-                        <a:t>___</a:t>
+                        <a:t>81.8%</a:t>
                       </a:r>
                     </a:p>
                   </a:txBody>
@@ -6418,7 +6422,7 @@
                         </a:defRPr>
                       </a:pPr>
                       <a:r>
-                        <a:t>___</a:t>
+                        <a:t>19.7%</a:t>
                       </a:r>
                     </a:p>
                   </a:txBody>
@@ -6442,7 +6446,7 @@
                         </a:defRPr>
                       </a:pPr>
                       <a:r>
-                        <a:t>___</a:t>
+                        <a:t>82.6%</a:t>
                       </a:r>
                     </a:p>
                   </a:txBody>
@@ -6492,7 +6496,7 @@
                         </a:defRPr>
                       </a:pPr>
                       <a:r>
-                        <a:t>___</a:t>
+                        <a:t>60.0%</a:t>
                       </a:r>
                     </a:p>
                   </a:txBody>
@@ -6516,7 +6520,7 @@
                         </a:defRPr>
                       </a:pPr>
                       <a:r>
-                        <a:t>___</a:t>
+                        <a:t>65.0%</a:t>
                       </a:r>
                     </a:p>
                   </a:txBody>
@@ -6540,7 +6544,7 @@
                         </a:defRPr>
                       </a:pPr>
                       <a:r>
-                        <a:t>___</a:t>
+                        <a:t>76.0%</a:t>
                       </a:r>
                     </a:p>
                   </a:txBody>
@@ -6564,7 +6568,7 @@
                         </a:defRPr>
                       </a:pPr>
                       <a:r>
-                        <a:t>___</a:t>
+                        <a:t>26.4%</a:t>
                       </a:r>
                     </a:p>
                   </a:txBody>
@@ -6588,7 +6592,7 @@
                         </a:defRPr>
                       </a:pPr>
                       <a:r>
-                        <a:t>___</a:t>
+                        <a:t>73.5%</a:t>
                       </a:r>
                     </a:p>
                   </a:txBody>
@@ -6723,7 +6727,7 @@
               </a:defRPr>
             </a:pPr>
             <a:r>
-              <a:t>• Model is ~95% confident on average</a:t>
+              <a:t>• Model stays ~99.9% confident on average</a:t>
             </a:r>
           </a:p>
           <a:p>
@@ -6739,7 +6743,7 @@
               </a:defRPr>
             </a:pPr>
             <a:r>
-              <a:t>• But accuracy drops to ~70% under heavy drift</a:t>
+              <a:t>• But accuracy collapses to 26.4% at segment 5</a:t>
             </a:r>
           </a:p>
           <a:p>
@@ -6787,7 +6791,7 @@
               </a:defRPr>
             </a:pPr>
             <a:r>
-              <a:t>• Accuracy spirals downward over time</a:t>
+              <a:t>• Accuracy stays below 50% across every segment</a:t>
             </a:r>
           </a:p>
         </p:txBody>
@@ -7183,7 +7187,7 @@
         <p:spPr>
           <a:xfrm>
             <a:off x="731520" y="1097280"/>
-            <a:ext cx="4572000" cy="365760"/>
+            <a:ext cx="5486400" cy="365760"/>
           </a:xfrm>
           <a:prstGeom prst="rect">
             <a:avLst/>
@@ -7199,13 +7203,13 @@
             <a:pPr algn="l">
               <a:defRPr sz="1400" b="0">
                 <a:solidFill>
-                  <a:srgbClr val="FAB387"/>
-                </a:solidFill>
-                <a:latin typeface="Calibri"/>
-              </a:defRPr>
-            </a:pPr>
-            <a:r>
-              <a:t>⚠️ Fill in after running notebook</a:t>
+                  <a:srgbClr val="A6ADC8"/>
+                </a:solidFill>
+                <a:latin typeface="Calibri"/>
+              </a:defRPr>
+            </a:pPr>
+            <a:r>
+              <a:t>Even 1–2% true-label rate holds accuracy within ~6pp of static</a:t>
             </a:r>
           </a:p>
         </p:txBody>
@@ -7370,7 +7374,7 @@
                         </a:defRPr>
                       </a:pPr>
                       <a:r>
-                        <a:t>____%</a:t>
+                        <a:t>86.4%</a:t>
                       </a:r>
                     </a:p>
                   </a:txBody>
@@ -7444,7 +7448,7 @@
                         </a:defRPr>
                       </a:pPr>
                       <a:r>
-                        <a:t>____%</a:t>
+                        <a:t>84.2%</a:t>
                       </a:r>
                     </a:p>
                   </a:txBody>
@@ -7518,7 +7522,7 @@
                         </a:defRPr>
                       </a:pPr>
                       <a:r>
-                        <a:t>____%</a:t>
+                        <a:t>80.7%</a:t>
                       </a:r>
                     </a:p>
                   </a:txBody>
@@ -7592,7 +7596,7 @@
                         </a:defRPr>
                       </a:pPr>
                       <a:r>
-                        <a:t>____%</a:t>
+                        <a:t>73.6%</a:t>
                       </a:r>
                     </a:p>
                   </a:txBody>
@@ -7666,7 +7670,7 @@
                         </a:defRPr>
                       </a:pPr>
                       <a:r>
-                        <a:t>____%</a:t>
+                        <a:t>80.9%</a:t>
                       </a:r>
                     </a:p>
                   </a:txBody>
@@ -7740,7 +7744,7 @@
                         </a:defRPr>
                       </a:pPr>
                       <a:r>
-                        <a:t>____%</a:t>
+                        <a:t>58.3%</a:t>
                       </a:r>
                     </a:p>
                   </a:txBody>
@@ -7814,7 +7818,7 @@
                         </a:defRPr>
                       </a:pPr>
                       <a:r>
-                        <a:t>____%</a:t>
+                        <a:t>86.1%</a:t>
                       </a:r>
                     </a:p>
                   </a:txBody>
@@ -8766,11 +8770,11 @@
               </a:defRPr>
             </a:pPr>
             <a:r>
-              <a:t>Hybrid: ____%</a:t>
+              <a:t>Hybrid: 85.7%</a:t>
             </a:r>
             <a:br/>
             <a:r>
-              <a:t>Static: ____%</a:t>
+              <a:t>Static: 86.1%</a:t>
             </a:r>
           </a:p>
         </p:txBody>
@@ -9196,7 +9200,7 @@
               </a:defRPr>
             </a:pPr>
             <a:r>
-              <a:t>Periodic recalibration + pseudo-labels beats pure self-training</a:t>
+              <a:t>Periodic recalibration prevents pseudo-label collapse while static decoders cannot adapt at all</a:t>
             </a:r>
           </a:p>
         </p:txBody>

</xml_diff>